<commit_message>
Course materials in English, Japanese and Chinese; lab conductor; slide 23 corrected
</commit_message>
<xml_diff>
--- a/04. Governed_AI_on_SAP_BTP.pptx
+++ b/04. Governed_AI_on_SAP_BTP.pptx
@@ -23729,7 +23729,7 @@
                 <a:ea typeface="Arial" pitchFamily="34" charset="-122"/>
                 <a:cs typeface="Arial" pitchFamily="34" charset="-120"/>
               </a:rPr>
-              <a:t>Eight labs, one element each</a:t>
+              <a:t>Eight labs, one element each. Six today, two next</a:t>
             </a:r>
             <a:endParaRPr lang="en-US" sz="2800" dirty="0"/>
           </a:p>
@@ -23750,7 +23750,7 @@
           </p:nvPr>
         </p:nvGraphicFramePr>
         <p:xfrm>
-          <a:off x="812800" y="2099469"/>
+          <a:off x="812800" y="1600000"/>
           <a:ext cx="10566400" cy="914400"/>
         </p:xfrm>
         <a:graphic>
@@ -23760,7 +23760,8 @@
               <a:tblGrid>
                 <a:gridCol w="844748"/>
                 <a:gridCol w="2956719"/>
-                <a:gridCol w="6758583"/>
+                <a:gridCol w="4250000"/>
+                <a:gridCol w="2508583"/>
               </a:tblGrid>
               <a:tr h="333970">
                 <a:tc>
@@ -23772,7 +23773,7 @@
                         <a:buNone/>
                       </a:pPr>
                       <a:r>
-                        <a:rPr lang="en-US" sz="1400" b="1" dirty="0">
+                        <a:rPr lang="en-US" sz="1200" b="1" dirty="0">
                           <a:solidFill>
                             <a:srgbClr val="F4F1EA"/>
                           </a:solidFill>
@@ -23840,7 +23841,7 @@
                         <a:buNone/>
                       </a:pPr>
                       <a:r>
-                        <a:rPr lang="en-US" sz="1400" b="1" dirty="0">
+                        <a:rPr lang="en-US" sz="1200" b="1" dirty="0">
                           <a:solidFill>
                             <a:srgbClr val="F4F1EA"/>
                           </a:solidFill>
@@ -23908,7 +23909,7 @@
                         <a:buNone/>
                       </a:pPr>
                       <a:r>
-                        <a:rPr lang="en-US" sz="1400" b="1" dirty="0">
+                        <a:rPr lang="en-US" sz="1200" b="1" dirty="0">
                           <a:solidFill>
                             <a:srgbClr val="F4F1EA"/>
                           </a:solidFill>
@@ -23967,6 +23968,74 @@
                     </a:solidFill>
                   </a:tcPr>
                 </a:tc>
+                <a:tc>
+                  <a:txBody>
+                    <a:bodyPr/>
+                    <a:lstStyle/>
+                    <a:p>
+                      <a:pPr algn="l" indent="0" marL="0">
+                        <a:buNone/>
+                      </a:pPr>
+                      <a:r>
+                        <a:rPr lang="en-US" sz="1200" b="1" dirty="0">
+                          <a:solidFill>
+                            <a:srgbClr val="F4F1EA"/>
+                          </a:solidFill>
+                          <a:latin typeface="Arial" pitchFamily="34" charset="0"/>
+                          <a:ea typeface="Arial" pitchFamily="34" charset="-122"/>
+                          <a:cs typeface="Arial" pitchFamily="34" charset="-120"/>
+                        </a:rPr>
+                        <a:t>In this session</a:t>
+                      </a:r>
+                      <a:endParaRPr lang="en-US" sz="1400" dirty="0">
+                        <a:latin typeface="Arial" charset="0"/>
+                        <a:ea typeface="Arial" charset="0"/>
+                        <a:cs typeface="Arial" charset="0"/>
+                      </a:endParaRPr>
+                    </a:p>
+                  </a:txBody>
+                  <a:tcPr marL="106680" marR="106680" marT="62230" marB="62230" anchor="t">
+                    <a:lnL w="6350" cap="flat" cmpd="sng" algn="ctr">
+                      <a:solidFill>
+                        <a:srgbClr val="CFC8BC"/>
+                      </a:solidFill>
+                      <a:prstDash val="solid"/>
+                      <a:round/>
+                      <a:headEnd type="none" w="med" len="med"/>
+                      <a:tailEnd type="none" w="med" len="med"/>
+                    </a:lnL>
+                    <a:lnR w="6350" cap="flat" cmpd="sng" algn="ctr">
+                      <a:solidFill>
+                        <a:srgbClr val="CFC8BC"/>
+                      </a:solidFill>
+                      <a:prstDash val="solid"/>
+                      <a:round/>
+                      <a:headEnd type="none" w="med" len="med"/>
+                      <a:tailEnd type="none" w="med" len="med"/>
+                    </a:lnR>
+                    <a:lnT w="6350" cap="flat" cmpd="sng" algn="ctr">
+                      <a:solidFill>
+                        <a:srgbClr val="CFC8BC"/>
+                      </a:solidFill>
+                      <a:prstDash val="solid"/>
+                      <a:round/>
+                      <a:headEnd type="none" w="med" len="med"/>
+                      <a:tailEnd type="none" w="med" len="med"/>
+                    </a:lnT>
+                    <a:lnB w="6350" cap="flat" cmpd="sng" algn="ctr">
+                      <a:solidFill>
+                        <a:srgbClr val="CFC8BC"/>
+                      </a:solidFill>
+                      <a:prstDash val="solid"/>
+                      <a:round/>
+                      <a:headEnd type="none" w="med" len="med"/>
+                      <a:tailEnd type="none" w="med" len="med"/>
+                    </a:lnB>
+                    <a:solidFill>
+                      <a:srgbClr val="0B192C"/>
+                    </a:solidFill>
+                  </a:tcPr>
+                </a:tc>
               </a:tr>
               <a:tr h="333970">
                 <a:tc>
@@ -23978,7 +24047,7 @@
                         <a:buNone/>
                       </a:pPr>
                       <a:r>
-                        <a:rPr lang="en-US" sz="1400" dirty="0">
+                        <a:rPr lang="en-US" sz="1200" dirty="0">
                           <a:solidFill>
                             <a:srgbClr val="0B192C"/>
                           </a:solidFill>
@@ -24046,7 +24115,7 @@
                         <a:buNone/>
                       </a:pPr>
                       <a:r>
-                        <a:rPr lang="en-US" sz="1400" dirty="0">
+                        <a:rPr lang="en-US" sz="1200" dirty="0">
                           <a:solidFill>
                             <a:srgbClr val="0B192C"/>
                           </a:solidFill>
@@ -24114,7 +24183,7 @@
                         <a:buNone/>
                       </a:pPr>
                       <a:r>
-                        <a:rPr lang="en-US" sz="1400" dirty="0">
+                        <a:rPr lang="en-US" sz="1200" dirty="0">
                           <a:solidFill>
                             <a:srgbClr val="0B192C"/>
                           </a:solidFill>
@@ -24173,6 +24242,74 @@
                     </a:solidFill>
                   </a:tcPr>
                 </a:tc>
+                <a:tc>
+                  <a:txBody>
+                    <a:bodyPr/>
+                    <a:lstStyle/>
+                    <a:p>
+                      <a:pPr algn="l" indent="0" marL="0">
+                        <a:buNone/>
+                      </a:pPr>
+                      <a:r>
+                        <a:rPr lang="en-US" sz="1200" dirty="0">
+                          <a:solidFill>
+                            <a:srgbClr val="0B192C"/>
+                          </a:solidFill>
+                          <a:latin typeface="Arial" pitchFamily="34" charset="0"/>
+                          <a:ea typeface="Arial" pitchFamily="34" charset="-122"/>
+                          <a:cs typeface="Arial" pitchFamily="34" charset="-120"/>
+                        </a:rPr>
+                        <a:t>Part B, B1 to B6 (destinations next)</a:t>
+                      </a:r>
+                      <a:endParaRPr lang="en-US" sz="1400" dirty="0">
+                        <a:latin typeface="Arial" charset="0"/>
+                        <a:ea typeface="Arial" charset="0"/>
+                        <a:cs typeface="Arial" charset="0"/>
+                      </a:endParaRPr>
+                    </a:p>
+                  </a:txBody>
+                  <a:tcPr marL="106680" marR="106680" marT="62230" marB="62230" anchor="t">
+                    <a:lnL w="6350" cap="flat" cmpd="sng" algn="ctr">
+                      <a:solidFill>
+                        <a:srgbClr val="CFC8BC"/>
+                      </a:solidFill>
+                      <a:prstDash val="solid"/>
+                      <a:round/>
+                      <a:headEnd type="none" w="med" len="med"/>
+                      <a:tailEnd type="none" w="med" len="med"/>
+                    </a:lnL>
+                    <a:lnR w="6350" cap="flat" cmpd="sng" algn="ctr">
+                      <a:solidFill>
+                        <a:srgbClr val="CFC8BC"/>
+                      </a:solidFill>
+                      <a:prstDash val="solid"/>
+                      <a:round/>
+                      <a:headEnd type="none" w="med" len="med"/>
+                      <a:tailEnd type="none" w="med" len="med"/>
+                    </a:lnR>
+                    <a:lnT w="6350" cap="flat" cmpd="sng" algn="ctr">
+                      <a:solidFill>
+                        <a:srgbClr val="CFC8BC"/>
+                      </a:solidFill>
+                      <a:prstDash val="solid"/>
+                      <a:round/>
+                      <a:headEnd type="none" w="med" len="med"/>
+                      <a:tailEnd type="none" w="med" len="med"/>
+                    </a:lnT>
+                    <a:lnB w="6350" cap="flat" cmpd="sng" algn="ctr">
+                      <a:solidFill>
+                        <a:srgbClr val="CFC8BC"/>
+                      </a:solidFill>
+                      <a:prstDash val="solid"/>
+                      <a:round/>
+                      <a:headEnd type="none" w="med" len="med"/>
+                      <a:tailEnd type="none" w="med" len="med"/>
+                    </a:lnB>
+                    <a:solidFill>
+                      <a:srgbClr val="FFFEFB"/>
+                    </a:solidFill>
+                  </a:tcPr>
+                </a:tc>
               </a:tr>
               <a:tr h="333970">
                 <a:tc>
@@ -24184,7 +24321,7 @@
                         <a:buNone/>
                       </a:pPr>
                       <a:r>
-                        <a:rPr lang="en-US" sz="1400" dirty="0">
+                        <a:rPr lang="en-US" sz="1200" dirty="0">
                           <a:solidFill>
                             <a:srgbClr val="0B192C"/>
                           </a:solidFill>
@@ -24252,7 +24389,7 @@
                         <a:buNone/>
                       </a:pPr>
                       <a:r>
-                        <a:rPr lang="en-US" sz="1400" dirty="0">
+                        <a:rPr lang="en-US" sz="1200" dirty="0">
                           <a:solidFill>
                             <a:srgbClr val="0B192C"/>
                           </a:solidFill>
@@ -24320,7 +24457,7 @@
                         <a:buNone/>
                       </a:pPr>
                       <a:r>
-                        <a:rPr lang="en-US" sz="1400" dirty="0">
+                        <a:rPr lang="en-US" sz="1200" dirty="0">
                           <a:solidFill>
                             <a:srgbClr val="0B192C"/>
                           </a:solidFill>
@@ -24379,6 +24516,74 @@
                     </a:solidFill>
                   </a:tcPr>
                 </a:tc>
+                <a:tc>
+                  <a:txBody>
+                    <a:bodyPr/>
+                    <a:lstStyle/>
+                    <a:p>
+                      <a:pPr algn="l" indent="0" marL="0">
+                        <a:buNone/>
+                      </a:pPr>
+                      <a:r>
+                        <a:rPr lang="en-US" sz="1200" dirty="0">
+                          <a:solidFill>
+                            <a:srgbClr val="0B192C"/>
+                          </a:solidFill>
+                          <a:latin typeface="Arial" pitchFamily="34" charset="0"/>
+                          <a:ea typeface="Arial" pitchFamily="34" charset="-122"/>
+                          <a:cs typeface="Arial" pitchFamily="34" charset="-120"/>
+                        </a:rPr>
+                        <a:t>Live in Claude, then with the connector</a:t>
+                      </a:r>
+                      <a:endParaRPr lang="en-US" sz="1400" dirty="0">
+                        <a:latin typeface="Arial" charset="0"/>
+                        <a:ea typeface="Arial" charset="0"/>
+                        <a:cs typeface="Arial" charset="0"/>
+                      </a:endParaRPr>
+                    </a:p>
+                  </a:txBody>
+                  <a:tcPr marL="106680" marR="106680" marT="62230" marB="62230" anchor="t">
+                    <a:lnL w="6350" cap="flat" cmpd="sng" algn="ctr">
+                      <a:solidFill>
+                        <a:srgbClr val="CFC8BC"/>
+                      </a:solidFill>
+                      <a:prstDash val="solid"/>
+                      <a:round/>
+                      <a:headEnd type="none" w="med" len="med"/>
+                      <a:tailEnd type="none" w="med" len="med"/>
+                    </a:lnL>
+                    <a:lnR w="6350" cap="flat" cmpd="sng" algn="ctr">
+                      <a:solidFill>
+                        <a:srgbClr val="CFC8BC"/>
+                      </a:solidFill>
+                      <a:prstDash val="solid"/>
+                      <a:round/>
+                      <a:headEnd type="none" w="med" len="med"/>
+                      <a:tailEnd type="none" w="med" len="med"/>
+                    </a:lnR>
+                    <a:lnT w="6350" cap="flat" cmpd="sng" algn="ctr">
+                      <a:solidFill>
+                        <a:srgbClr val="CFC8BC"/>
+                      </a:solidFill>
+                      <a:prstDash val="solid"/>
+                      <a:round/>
+                      <a:headEnd type="none" w="med" len="med"/>
+                      <a:tailEnd type="none" w="med" len="med"/>
+                    </a:lnT>
+                    <a:lnB w="6350" cap="flat" cmpd="sng" algn="ctr">
+                      <a:solidFill>
+                        <a:srgbClr val="CFC8BC"/>
+                      </a:solidFill>
+                      <a:prstDash val="solid"/>
+                      <a:round/>
+                      <a:headEnd type="none" w="med" len="med"/>
+                      <a:tailEnd type="none" w="med" len="med"/>
+                    </a:lnB>
+                    <a:solidFill>
+                      <a:srgbClr val="F1EDE6"/>
+                    </a:solidFill>
+                  </a:tcPr>
+                </a:tc>
               </a:tr>
               <a:tr h="333970">
                 <a:tc>
@@ -24390,7 +24595,7 @@
                         <a:buNone/>
                       </a:pPr>
                       <a:r>
-                        <a:rPr lang="en-US" sz="1400" dirty="0">
+                        <a:rPr lang="en-US" sz="1200" dirty="0">
                           <a:solidFill>
                             <a:srgbClr val="0B192C"/>
                           </a:solidFill>
@@ -24458,7 +24663,7 @@
                         <a:buNone/>
                       </a:pPr>
                       <a:r>
-                        <a:rPr lang="en-US" sz="1400" dirty="0">
+                        <a:rPr lang="en-US" sz="1200" dirty="0">
                           <a:solidFill>
                             <a:srgbClr val="0B192C"/>
                           </a:solidFill>
@@ -24526,7 +24731,7 @@
                         <a:buNone/>
                       </a:pPr>
                       <a:r>
-                        <a:rPr lang="en-US" sz="1400" dirty="0">
+                        <a:rPr lang="en-US" sz="1200" dirty="0">
                           <a:solidFill>
                             <a:srgbClr val="0B192C"/>
                           </a:solidFill>
@@ -24585,6 +24790,74 @@
                     </a:solidFill>
                   </a:tcPr>
                 </a:tc>
+                <a:tc>
+                  <a:txBody>
+                    <a:bodyPr/>
+                    <a:lstStyle/>
+                    <a:p>
+                      <a:pPr algn="l" indent="0" marL="0">
+                        <a:buNone/>
+                      </a:pPr>
+                      <a:r>
+                        <a:rPr lang="en-US" sz="1200" dirty="0">
+                          <a:solidFill>
+                            <a:srgbClr val="0B192C"/>
+                          </a:solidFill>
+                          <a:latin typeface="Arial" pitchFamily="34" charset="0"/>
+                          <a:ea typeface="Arial" pitchFamily="34" charset="-122"/>
+                          <a:cs typeface="Arial" pitchFamily="34" charset="-120"/>
+                        </a:rPr>
+                        <a:t>Part A Ex. 2 · Part B B7</a:t>
+                      </a:r>
+                      <a:endParaRPr lang="en-US" sz="1400" dirty="0">
+                        <a:latin typeface="Arial" charset="0"/>
+                        <a:ea typeface="Arial" charset="0"/>
+                        <a:cs typeface="Arial" charset="0"/>
+                      </a:endParaRPr>
+                    </a:p>
+                  </a:txBody>
+                  <a:tcPr marL="106680" marR="106680" marT="62230" marB="62230" anchor="t">
+                    <a:lnL w="6350" cap="flat" cmpd="sng" algn="ctr">
+                      <a:solidFill>
+                        <a:srgbClr val="CFC8BC"/>
+                      </a:solidFill>
+                      <a:prstDash val="solid"/>
+                      <a:round/>
+                      <a:headEnd type="none" w="med" len="med"/>
+                      <a:tailEnd type="none" w="med" len="med"/>
+                    </a:lnL>
+                    <a:lnR w="6350" cap="flat" cmpd="sng" algn="ctr">
+                      <a:solidFill>
+                        <a:srgbClr val="CFC8BC"/>
+                      </a:solidFill>
+                      <a:prstDash val="solid"/>
+                      <a:round/>
+                      <a:headEnd type="none" w="med" len="med"/>
+                      <a:tailEnd type="none" w="med" len="med"/>
+                    </a:lnR>
+                    <a:lnT w="6350" cap="flat" cmpd="sng" algn="ctr">
+                      <a:solidFill>
+                        <a:srgbClr val="CFC8BC"/>
+                      </a:solidFill>
+                      <a:prstDash val="solid"/>
+                      <a:round/>
+                      <a:headEnd type="none" w="med" len="med"/>
+                      <a:tailEnd type="none" w="med" len="med"/>
+                    </a:lnT>
+                    <a:lnB w="6350" cap="flat" cmpd="sng" algn="ctr">
+                      <a:solidFill>
+                        <a:srgbClr val="CFC8BC"/>
+                      </a:solidFill>
+                      <a:prstDash val="solid"/>
+                      <a:round/>
+                      <a:headEnd type="none" w="med" len="med"/>
+                      <a:tailEnd type="none" w="med" len="med"/>
+                    </a:lnB>
+                    <a:solidFill>
+                      <a:srgbClr val="FFFEFB"/>
+                    </a:solidFill>
+                  </a:tcPr>
+                </a:tc>
               </a:tr>
               <a:tr h="333970">
                 <a:tc>
@@ -24596,7 +24869,7 @@
                         <a:buNone/>
                       </a:pPr>
                       <a:r>
-                        <a:rPr lang="en-US" sz="1400" dirty="0">
+                        <a:rPr lang="en-US" sz="1200" dirty="0">
                           <a:solidFill>
                             <a:srgbClr val="0B192C"/>
                           </a:solidFill>
@@ -24664,7 +24937,7 @@
                         <a:buNone/>
                       </a:pPr>
                       <a:r>
-                        <a:rPr lang="en-US" sz="1400" dirty="0">
+                        <a:rPr lang="en-US" sz="1200" dirty="0">
                           <a:solidFill>
                             <a:srgbClr val="0B192C"/>
                           </a:solidFill>
@@ -24732,7 +25005,7 @@
                         <a:buNone/>
                       </a:pPr>
                       <a:r>
-                        <a:rPr lang="en-US" sz="1400" dirty="0">
+                        <a:rPr lang="en-US" sz="1200" dirty="0">
                           <a:solidFill>
                             <a:srgbClr val="0B192C"/>
                           </a:solidFill>
@@ -24791,6 +25064,74 @@
                     </a:solidFill>
                   </a:tcPr>
                 </a:tc>
+                <a:tc>
+                  <a:txBody>
+                    <a:bodyPr/>
+                    <a:lstStyle/>
+                    <a:p>
+                      <a:pPr algn="l" indent="0" marL="0">
+                        <a:buNone/>
+                      </a:pPr>
+                      <a:r>
+                        <a:rPr lang="en-US" sz="1200" dirty="0">
+                          <a:solidFill>
+                            <a:srgbClr val="0B192C"/>
+                          </a:solidFill>
+                          <a:latin typeface="Arial" pitchFamily="34" charset="0"/>
+                          <a:ea typeface="Arial" pitchFamily="34" charset="-122"/>
+                          <a:cs typeface="Arial" pitchFamily="34" charset="-120"/>
+                        </a:rPr>
+                        <a:t>Part A A5, A6 · Part B B10, B11</a:t>
+                      </a:r>
+                      <a:endParaRPr lang="en-US" sz="1400" dirty="0">
+                        <a:latin typeface="Arial" charset="0"/>
+                        <a:ea typeface="Arial" charset="0"/>
+                        <a:cs typeface="Arial" charset="0"/>
+                      </a:endParaRPr>
+                    </a:p>
+                  </a:txBody>
+                  <a:tcPr marL="106680" marR="106680" marT="62230" marB="62230" anchor="t">
+                    <a:lnL w="6350" cap="flat" cmpd="sng" algn="ctr">
+                      <a:solidFill>
+                        <a:srgbClr val="CFC8BC"/>
+                      </a:solidFill>
+                      <a:prstDash val="solid"/>
+                      <a:round/>
+                      <a:headEnd type="none" w="med" len="med"/>
+                      <a:tailEnd type="none" w="med" len="med"/>
+                    </a:lnL>
+                    <a:lnR w="6350" cap="flat" cmpd="sng" algn="ctr">
+                      <a:solidFill>
+                        <a:srgbClr val="CFC8BC"/>
+                      </a:solidFill>
+                      <a:prstDash val="solid"/>
+                      <a:round/>
+                      <a:headEnd type="none" w="med" len="med"/>
+                      <a:tailEnd type="none" w="med" len="med"/>
+                    </a:lnR>
+                    <a:lnT w="6350" cap="flat" cmpd="sng" algn="ctr">
+                      <a:solidFill>
+                        <a:srgbClr val="CFC8BC"/>
+                      </a:solidFill>
+                      <a:prstDash val="solid"/>
+                      <a:round/>
+                      <a:headEnd type="none" w="med" len="med"/>
+                      <a:tailEnd type="none" w="med" len="med"/>
+                    </a:lnT>
+                    <a:lnB w="6350" cap="flat" cmpd="sng" algn="ctr">
+                      <a:solidFill>
+                        <a:srgbClr val="CFC8BC"/>
+                      </a:solidFill>
+                      <a:prstDash val="solid"/>
+                      <a:round/>
+                      <a:headEnd type="none" w="med" len="med"/>
+                      <a:tailEnd type="none" w="med" len="med"/>
+                    </a:lnB>
+                    <a:solidFill>
+                      <a:srgbClr val="F1EDE6"/>
+                    </a:solidFill>
+                  </a:tcPr>
+                </a:tc>
               </a:tr>
               <a:tr h="333970">
                 <a:tc>
@@ -24802,7 +25143,7 @@
                         <a:buNone/>
                       </a:pPr>
                       <a:r>
-                        <a:rPr lang="en-US" sz="1400" dirty="0">
+                        <a:rPr lang="en-US" sz="1200" dirty="0">
                           <a:solidFill>
                             <a:srgbClr val="0B192C"/>
                           </a:solidFill>
@@ -24870,7 +25211,7 @@
                         <a:buNone/>
                       </a:pPr>
                       <a:r>
-                        <a:rPr lang="en-US" sz="1400" dirty="0">
+                        <a:rPr lang="en-US" sz="1200" dirty="0">
                           <a:solidFill>
                             <a:srgbClr val="0B192C"/>
                           </a:solidFill>
@@ -24938,7 +25279,7 @@
                         <a:buNone/>
                       </a:pPr>
                       <a:r>
-                        <a:rPr lang="en-US" sz="1400" dirty="0">
+                        <a:rPr lang="en-US" sz="1200" dirty="0">
                           <a:solidFill>
                             <a:srgbClr val="0B192C"/>
                           </a:solidFill>
@@ -24997,6 +25338,74 @@
                     </a:solidFill>
                   </a:tcPr>
                 </a:tc>
+                <a:tc>
+                  <a:txBody>
+                    <a:bodyPr/>
+                    <a:lstStyle/>
+                    <a:p>
+                      <a:pPr algn="l" indent="0" marL="0">
+                        <a:buNone/>
+                      </a:pPr>
+                      <a:r>
+                        <a:rPr lang="en-US" sz="1200" dirty="0">
+                          <a:solidFill>
+                            <a:srgbClr val="0B192C"/>
+                          </a:solidFill>
+                          <a:latin typeface="Arial" pitchFamily="34" charset="0"/>
+                          <a:ea typeface="Arial" pitchFamily="34" charset="-122"/>
+                          <a:cs typeface="Arial" pitchFamily="34" charset="-120"/>
+                        </a:rPr>
+                        <a:t>Part A Ex. 1, 3 · Part B B14</a:t>
+                      </a:r>
+                      <a:endParaRPr lang="en-US" sz="1400" dirty="0">
+                        <a:latin typeface="Arial" charset="0"/>
+                        <a:ea typeface="Arial" charset="0"/>
+                        <a:cs typeface="Arial" charset="0"/>
+                      </a:endParaRPr>
+                    </a:p>
+                  </a:txBody>
+                  <a:tcPr marL="106680" marR="106680" marT="62230" marB="62230" anchor="t">
+                    <a:lnL w="6350" cap="flat" cmpd="sng" algn="ctr">
+                      <a:solidFill>
+                        <a:srgbClr val="CFC8BC"/>
+                      </a:solidFill>
+                      <a:prstDash val="solid"/>
+                      <a:round/>
+                      <a:headEnd type="none" w="med" len="med"/>
+                      <a:tailEnd type="none" w="med" len="med"/>
+                    </a:lnL>
+                    <a:lnR w="6350" cap="flat" cmpd="sng" algn="ctr">
+                      <a:solidFill>
+                        <a:srgbClr val="CFC8BC"/>
+                      </a:solidFill>
+                      <a:prstDash val="solid"/>
+                      <a:round/>
+                      <a:headEnd type="none" w="med" len="med"/>
+                      <a:tailEnd type="none" w="med" len="med"/>
+                    </a:lnR>
+                    <a:lnT w="6350" cap="flat" cmpd="sng" algn="ctr">
+                      <a:solidFill>
+                        <a:srgbClr val="CFC8BC"/>
+                      </a:solidFill>
+                      <a:prstDash val="solid"/>
+                      <a:round/>
+                      <a:headEnd type="none" w="med" len="med"/>
+                      <a:tailEnd type="none" w="med" len="med"/>
+                    </a:lnT>
+                    <a:lnB w="6350" cap="flat" cmpd="sng" algn="ctr">
+                      <a:solidFill>
+                        <a:srgbClr val="CFC8BC"/>
+                      </a:solidFill>
+                      <a:prstDash val="solid"/>
+                      <a:round/>
+                      <a:headEnd type="none" w="med" len="med"/>
+                      <a:tailEnd type="none" w="med" len="med"/>
+                    </a:lnB>
+                    <a:solidFill>
+                      <a:srgbClr val="FFFEFB"/>
+                    </a:solidFill>
+                  </a:tcPr>
+                </a:tc>
               </a:tr>
               <a:tr h="333970">
                 <a:tc>
@@ -25008,7 +25417,7 @@
                         <a:buNone/>
                       </a:pPr>
                       <a:r>
-                        <a:rPr lang="en-US" sz="1400" dirty="0">
+                        <a:rPr lang="en-US" sz="1200" dirty="0">
                           <a:solidFill>
                             <a:srgbClr val="0B192C"/>
                           </a:solidFill>
@@ -25076,7 +25485,7 @@
                         <a:buNone/>
                       </a:pPr>
                       <a:r>
-                        <a:rPr lang="en-US" sz="1400" dirty="0">
+                        <a:rPr lang="en-US" sz="1200" dirty="0">
                           <a:solidFill>
                             <a:srgbClr val="0B192C"/>
                           </a:solidFill>
@@ -25144,7 +25553,7 @@
                         <a:buNone/>
                       </a:pPr>
                       <a:r>
-                        <a:rPr lang="en-US" sz="1400" dirty="0">
+                        <a:rPr lang="en-US" sz="1200" dirty="0">
                           <a:solidFill>
                             <a:srgbClr val="0B192C"/>
                           </a:solidFill>
@@ -25203,6 +25612,74 @@
                     </a:solidFill>
                   </a:tcPr>
                 </a:tc>
+                <a:tc>
+                  <a:txBody>
+                    <a:bodyPr/>
+                    <a:lstStyle/>
+                    <a:p>
+                      <a:pPr algn="l" indent="0" marL="0">
+                        <a:buNone/>
+                      </a:pPr>
+                      <a:r>
+                        <a:rPr lang="en-US" sz="1200" dirty="0">
+                          <a:solidFill>
+                            <a:srgbClr val="0B192C"/>
+                          </a:solidFill>
+                          <a:latin typeface="Arial" pitchFamily="34" charset="0"/>
+                          <a:ea typeface="Arial" pitchFamily="34" charset="-122"/>
+                          <a:cs typeface="Arial" pitchFamily="34" charset="-120"/>
+                        </a:rPr>
+                        <a:t>Next phase (Stage B)</a:t>
+                      </a:r>
+                      <a:endParaRPr lang="en-US" sz="1400" dirty="0">
+                        <a:latin typeface="Arial" charset="0"/>
+                        <a:ea typeface="Arial" charset="0"/>
+                        <a:cs typeface="Arial" charset="0"/>
+                      </a:endParaRPr>
+                    </a:p>
+                  </a:txBody>
+                  <a:tcPr marL="106680" marR="106680" marT="62230" marB="62230" anchor="t">
+                    <a:lnL w="6350" cap="flat" cmpd="sng" algn="ctr">
+                      <a:solidFill>
+                        <a:srgbClr val="CFC8BC"/>
+                      </a:solidFill>
+                      <a:prstDash val="solid"/>
+                      <a:round/>
+                      <a:headEnd type="none" w="med" len="med"/>
+                      <a:tailEnd type="none" w="med" len="med"/>
+                    </a:lnL>
+                    <a:lnR w="6350" cap="flat" cmpd="sng" algn="ctr">
+                      <a:solidFill>
+                        <a:srgbClr val="CFC8BC"/>
+                      </a:solidFill>
+                      <a:prstDash val="solid"/>
+                      <a:round/>
+                      <a:headEnd type="none" w="med" len="med"/>
+                      <a:tailEnd type="none" w="med" len="med"/>
+                    </a:lnR>
+                    <a:lnT w="6350" cap="flat" cmpd="sng" algn="ctr">
+                      <a:solidFill>
+                        <a:srgbClr val="CFC8BC"/>
+                      </a:solidFill>
+                      <a:prstDash val="solid"/>
+                      <a:round/>
+                      <a:headEnd type="none" w="med" len="med"/>
+                      <a:tailEnd type="none" w="med" len="med"/>
+                    </a:lnT>
+                    <a:lnB w="6350" cap="flat" cmpd="sng" algn="ctr">
+                      <a:solidFill>
+                        <a:srgbClr val="CFC8BC"/>
+                      </a:solidFill>
+                      <a:prstDash val="solid"/>
+                      <a:round/>
+                      <a:headEnd type="none" w="med" len="med"/>
+                      <a:tailEnd type="none" w="med" len="med"/>
+                    </a:lnB>
+                    <a:solidFill>
+                      <a:srgbClr val="F1EDE6"/>
+                    </a:solidFill>
+                  </a:tcPr>
+                </a:tc>
               </a:tr>
               <a:tr h="333970">
                 <a:tc>
@@ -25214,7 +25691,7 @@
                         <a:buNone/>
                       </a:pPr>
                       <a:r>
-                        <a:rPr lang="en-US" sz="1400" dirty="0">
+                        <a:rPr lang="en-US" sz="1200" dirty="0">
                           <a:solidFill>
                             <a:srgbClr val="0B192C"/>
                           </a:solidFill>
@@ -25282,7 +25759,7 @@
                         <a:buNone/>
                       </a:pPr>
                       <a:r>
-                        <a:rPr lang="en-US" sz="1400" dirty="0">
+                        <a:rPr lang="en-US" sz="1200" dirty="0">
                           <a:solidFill>
                             <a:srgbClr val="0B192C"/>
                           </a:solidFill>
@@ -25350,7 +25827,7 @@
                         <a:buNone/>
                       </a:pPr>
                       <a:r>
-                        <a:rPr lang="en-US" sz="1400" dirty="0">
+                        <a:rPr lang="en-US" sz="1200" dirty="0">
                           <a:solidFill>
                             <a:srgbClr val="0B192C"/>
                           </a:solidFill>
@@ -25409,6 +25886,74 @@
                     </a:solidFill>
                   </a:tcPr>
                 </a:tc>
+                <a:tc>
+                  <a:txBody>
+                    <a:bodyPr/>
+                    <a:lstStyle/>
+                    <a:p>
+                      <a:pPr algn="l" indent="0" marL="0">
+                        <a:buNone/>
+                      </a:pPr>
+                      <a:r>
+                        <a:rPr lang="en-US" sz="1200" dirty="0">
+                          <a:solidFill>
+                            <a:srgbClr val="0B192C"/>
+                          </a:solidFill>
+                          <a:latin typeface="Arial" pitchFamily="34" charset="0"/>
+                          <a:ea typeface="Arial" pitchFamily="34" charset="-122"/>
+                          <a:cs typeface="Arial" pitchFamily="34" charset="-120"/>
+                        </a:rPr>
+                        <a:t>Part A Ex. 4</a:t>
+                      </a:r>
+                      <a:endParaRPr lang="en-US" sz="1400" dirty="0">
+                        <a:latin typeface="Arial" charset="0"/>
+                        <a:ea typeface="Arial" charset="0"/>
+                        <a:cs typeface="Arial" charset="0"/>
+                      </a:endParaRPr>
+                    </a:p>
+                  </a:txBody>
+                  <a:tcPr marL="106680" marR="106680" marT="62230" marB="62230" anchor="t">
+                    <a:lnL w="6350" cap="flat" cmpd="sng" algn="ctr">
+                      <a:solidFill>
+                        <a:srgbClr val="CFC8BC"/>
+                      </a:solidFill>
+                      <a:prstDash val="solid"/>
+                      <a:round/>
+                      <a:headEnd type="none" w="med" len="med"/>
+                      <a:tailEnd type="none" w="med" len="med"/>
+                    </a:lnL>
+                    <a:lnR w="6350" cap="flat" cmpd="sng" algn="ctr">
+                      <a:solidFill>
+                        <a:srgbClr val="CFC8BC"/>
+                      </a:solidFill>
+                      <a:prstDash val="solid"/>
+                      <a:round/>
+                      <a:headEnd type="none" w="med" len="med"/>
+                      <a:tailEnd type="none" w="med" len="med"/>
+                    </a:lnR>
+                    <a:lnT w="6350" cap="flat" cmpd="sng" algn="ctr">
+                      <a:solidFill>
+                        <a:srgbClr val="CFC8BC"/>
+                      </a:solidFill>
+                      <a:prstDash val="solid"/>
+                      <a:round/>
+                      <a:headEnd type="none" w="med" len="med"/>
+                      <a:tailEnd type="none" w="med" len="med"/>
+                    </a:lnT>
+                    <a:lnB w="6350" cap="flat" cmpd="sng" algn="ctr">
+                      <a:solidFill>
+                        <a:srgbClr val="CFC8BC"/>
+                      </a:solidFill>
+                      <a:prstDash val="solid"/>
+                      <a:round/>
+                      <a:headEnd type="none" w="med" len="med"/>
+                      <a:tailEnd type="none" w="med" len="med"/>
+                    </a:lnB>
+                    <a:solidFill>
+                      <a:srgbClr val="FFFEFB"/>
+                    </a:solidFill>
+                  </a:tcPr>
+                </a:tc>
               </a:tr>
               <a:tr h="333970">
                 <a:tc>
@@ -25420,7 +25965,7 @@
                         <a:buNone/>
                       </a:pPr>
                       <a:r>
-                        <a:rPr lang="en-US" sz="1400" dirty="0">
+                        <a:rPr lang="en-US" sz="1200" dirty="0">
                           <a:solidFill>
                             <a:srgbClr val="0B192C"/>
                           </a:solidFill>
@@ -25488,7 +26033,7 @@
                         <a:buNone/>
                       </a:pPr>
                       <a:r>
-                        <a:rPr lang="en-US" sz="1400" dirty="0">
+                        <a:rPr lang="en-US" sz="1200" dirty="0">
                           <a:solidFill>
                             <a:srgbClr val="0B192C"/>
                           </a:solidFill>
@@ -25556,7 +26101,7 @@
                         <a:buNone/>
                       </a:pPr>
                       <a:r>
-                        <a:rPr lang="en-US" sz="1400" dirty="0">
+                        <a:rPr lang="en-US" sz="1200" dirty="0">
                           <a:solidFill>
                             <a:srgbClr val="0B192C"/>
                           </a:solidFill>
@@ -25615,6 +26160,74 @@
                     </a:solidFill>
                   </a:tcPr>
                 </a:tc>
+                <a:tc>
+                  <a:txBody>
+                    <a:bodyPr/>
+                    <a:lstStyle/>
+                    <a:p>
+                      <a:pPr algn="l" indent="0" marL="0">
+                        <a:buNone/>
+                      </a:pPr>
+                      <a:r>
+                        <a:rPr lang="en-US" sz="1200" dirty="0">
+                          <a:solidFill>
+                            <a:srgbClr val="0B192C"/>
+                          </a:solidFill>
+                          <a:latin typeface="Arial" pitchFamily="34" charset="0"/>
+                          <a:ea typeface="Arial" pitchFamily="34" charset="-122"/>
+                          <a:cs typeface="Arial" pitchFamily="34" charset="-120"/>
+                        </a:rPr>
+                        <a:t>Next phase; today the lab journal</a:t>
+                      </a:r>
+                      <a:endParaRPr lang="en-US" sz="1400" dirty="0">
+                        <a:latin typeface="Arial" charset="0"/>
+                        <a:ea typeface="Arial" charset="0"/>
+                        <a:cs typeface="Arial" charset="0"/>
+                      </a:endParaRPr>
+                    </a:p>
+                  </a:txBody>
+                  <a:tcPr marL="106680" marR="106680" marT="62230" marB="62230" anchor="t">
+                    <a:lnL w="6350" cap="flat" cmpd="sng" algn="ctr">
+                      <a:solidFill>
+                        <a:srgbClr val="CFC8BC"/>
+                      </a:solidFill>
+                      <a:prstDash val="solid"/>
+                      <a:round/>
+                      <a:headEnd type="none" w="med" len="med"/>
+                      <a:tailEnd type="none" w="med" len="med"/>
+                    </a:lnL>
+                    <a:lnR w="6350" cap="flat" cmpd="sng" algn="ctr">
+                      <a:solidFill>
+                        <a:srgbClr val="CFC8BC"/>
+                      </a:solidFill>
+                      <a:prstDash val="solid"/>
+                      <a:round/>
+                      <a:headEnd type="none" w="med" len="med"/>
+                      <a:tailEnd type="none" w="med" len="med"/>
+                    </a:lnR>
+                    <a:lnT w="6350" cap="flat" cmpd="sng" algn="ctr">
+                      <a:solidFill>
+                        <a:srgbClr val="CFC8BC"/>
+                      </a:solidFill>
+                      <a:prstDash val="solid"/>
+                      <a:round/>
+                      <a:headEnd type="none" w="med" len="med"/>
+                      <a:tailEnd type="none" w="med" len="med"/>
+                    </a:lnT>
+                    <a:lnB w="6350" cap="flat" cmpd="sng" algn="ctr">
+                      <a:solidFill>
+                        <a:srgbClr val="CFC8BC"/>
+                      </a:solidFill>
+                      <a:prstDash val="solid"/>
+                      <a:round/>
+                      <a:headEnd type="none" w="med" len="med"/>
+                      <a:tailEnd type="none" w="med" len="med"/>
+                    </a:lnB>
+                    <a:solidFill>
+                      <a:srgbClr val="F1EDE6"/>
+                    </a:solidFill>
+                  </a:tcPr>
+                </a:tc>
               </a:tr>
             </a:tbl>
           </a:graphicData>
@@ -25644,6 +26257,10 @@
             <a:tailEnd type="none"/>
           </a:ln>
         </p:spPr>
+        <p:txBody>
+          <a:bodyPr/>
+          <a:p/>
+        </p:txBody>
       </p:sp>
       <p:sp>
         <p:nvSpPr>

</xml_diff>